<commit_message>
test(landing): verify visit demo exports and production rendering
</commit_message>
<xml_diff>
--- a/frontend/public/landing/samples/clean-energy-briefing.pptx
+++ b/frontend/public/landing/samples/clean-energy-briefing.pptx
@@ -6192,107 +6192,7 @@
       </p:sp>
       <p:sp>
         <p:nvSpPr>
-          <p:cNvPr id="4" name="TextBox 3"/>
-          <p:cNvSpPr txBox="1"/>
-          <p:nvPr/>
-        </p:nvSpPr>
-        <p:spPr>
-          <a:xfrm>
-            <a:off x="640080" y="3383280"/>
-            <a:ext cx="6400800" cy="2286000"/>
-          </a:xfrm>
-          <a:prstGeom prst="rect">
-            <a:avLst/>
-          </a:prstGeom>
-          <a:noFill/>
-        </p:spPr>
-        <p:txBody>
-          <a:bodyPr wrap="square">
-            <a:spAutoFit/>
-          </a:bodyPr>
-          <a:lstStyle/>
-          <a:p>
-            <a:pPr>
-              <a:spcAft>
-                <a:spcPts val="1200"/>
-              </a:spcAft>
-              <a:defRPr sz="2300" b="0">
-                <a:solidFill>
-                  <a:srgbClr val="223E30"/>
-                </a:solidFill>
-                <a:latin typeface="Calibri"/>
-              </a:defRPr>
-            </a:pPr>
-            <a:r>
-              <a:t>Renewables 2025</a:t>
-            </a:r>
-          </a:p>
-          <a:p>
-            <a:pPr>
-              <a:spcAft>
-                <a:spcPts val="1200"/>
-              </a:spcAft>
-              <a:defRPr sz="2300" b="0">
-                <a:solidFill>
-                  <a:srgbClr val="223E30"/>
-                </a:solidFill>
-                <a:latin typeface="Calibri"/>
-              </a:defRPr>
-            </a:pPr>
-            <a:r>
-              <a:t>International Energy Agency</a:t>
-            </a:r>
-          </a:p>
-          <a:p>
-            <a:pPr>
-              <a:spcAft>
-                <a:spcPts val="1200"/>
-              </a:spcAft>
-              <a:defRPr sz="2300" b="0">
-                <a:solidFill>
-                  <a:srgbClr val="223E30"/>
-                </a:solidFill>
-                <a:latin typeface="Calibri"/>
-              </a:defRPr>
-            </a:pPr>
-          </a:p>
-          <a:p>
-            <a:pPr>
-              <a:spcAft>
-                <a:spcPts val="1200"/>
-              </a:spcAft>
-              <a:defRPr sz="2300" b="0">
-                <a:solidFill>
-                  <a:srgbClr val="223E30"/>
-                </a:solidFill>
-                <a:latin typeface="Calibri"/>
-              </a:defRPr>
-            </a:pPr>
-            <a:r>
-              <a:t>Energy Storage</a:t>
-            </a:r>
-          </a:p>
-          <a:p>
-            <a:pPr>
-              <a:spcAft>
-                <a:spcPts val="1200"/>
-              </a:spcAft>
-              <a:defRPr sz="2300" b="0">
-                <a:solidFill>
-                  <a:srgbClr val="223E30"/>
-                </a:solidFill>
-                <a:latin typeface="Calibri"/>
-              </a:defRPr>
-            </a:pPr>
-            <a:r>
-              <a:t>US Department of Energy</a:t>
-            </a:r>
-          </a:p>
-        </p:txBody>
-      </p:sp>
-      <p:sp>
-        <p:nvSpPr>
-          <p:cNvPr id="5" name="Rectangle 4"/>
+          <p:cNvPr id="4" name="Rectangle 3"/>
           <p:cNvSpPr/>
           <p:nvPr/>
         </p:nvSpPr>
@@ -6335,14 +6235,49 @@
       </p:sp>
       <p:cxnSp>
         <p:nvCxnSpPr>
+          <p:cNvPr id="5" name="Connector 4"/>
+          <p:cNvCxnSpPr/>
+          <p:nvPr/>
+        </p:nvCxnSpPr>
+        <p:spPr>
+          <a:xfrm>
+            <a:off x="8686800" y="3108960"/>
+            <a:ext cx="0" cy="1920240"/>
+          </a:xfrm>
+          <a:prstGeom prst="line">
+            <a:avLst/>
+          </a:prstGeom>
+          <a:ln w="38100">
+            <a:solidFill>
+              <a:srgbClr val="56705F"/>
+            </a:solidFill>
+          </a:ln>
+        </p:spPr>
+        <p:style>
+          <a:lnRef idx="2">
+            <a:schemeClr val="accent1"/>
+          </a:lnRef>
+          <a:fillRef idx="0">
+            <a:schemeClr val="accent1"/>
+          </a:fillRef>
+          <a:effectRef idx="1">
+            <a:schemeClr val="accent1"/>
+          </a:effectRef>
+          <a:fontRef idx="minor">
+            <a:schemeClr val="tx1"/>
+          </a:fontRef>
+        </p:style>
+      </p:cxnSp>
+      <p:cxnSp>
+        <p:nvCxnSpPr>
           <p:cNvPr id="6" name="Connector 5"/>
           <p:cNvCxnSpPr/>
           <p:nvPr/>
         </p:nvCxnSpPr>
         <p:spPr>
-          <a:xfrm>
-            <a:off x="8686800" y="3108960"/>
-            <a:ext cx="0" cy="1920240"/>
+          <a:xfrm flipV="1">
+            <a:off x="8686800" y="2468880"/>
+            <a:ext cx="0" cy="640080"/>
           </a:xfrm>
           <a:prstGeom prst="line">
             <a:avLst/>
@@ -6375,9 +6310,9 @@
           <p:nvPr/>
         </p:nvCxnSpPr>
         <p:spPr>
-          <a:xfrm flipV="1">
-            <a:off x="8686800" y="2468880"/>
-            <a:ext cx="0" cy="640080"/>
+          <a:xfrm>
+            <a:off x="8686800" y="3108960"/>
+            <a:ext cx="548640" cy="274319"/>
           </a:xfrm>
           <a:prstGeom prst="line">
             <a:avLst/>
@@ -6410,8 +6345,8 @@
           <p:nvPr/>
         </p:nvCxnSpPr>
         <p:spPr>
-          <a:xfrm>
-            <a:off x="8686800" y="3108960"/>
+          <a:xfrm flipH="1">
+            <a:off x="8138160" y="3108960"/>
             <a:ext cx="548640" cy="274319"/>
           </a:xfrm>
           <a:prstGeom prst="line">
@@ -6445,9 +6380,9 @@
           <p:nvPr/>
         </p:nvCxnSpPr>
         <p:spPr>
-          <a:xfrm flipH="1">
-            <a:off x="8138160" y="3108960"/>
-            <a:ext cx="548640" cy="274319"/>
+          <a:xfrm>
+            <a:off x="10058400" y="2286000"/>
+            <a:ext cx="0" cy="2743200"/>
           </a:xfrm>
           <a:prstGeom prst="line">
             <a:avLst/>
@@ -6480,9 +6415,9 @@
           <p:nvPr/>
         </p:nvCxnSpPr>
         <p:spPr>
-          <a:xfrm>
-            <a:off x="10058400" y="2286000"/>
-            <a:ext cx="0" cy="2743200"/>
+          <a:xfrm flipV="1">
+            <a:off x="10058400" y="1645920"/>
+            <a:ext cx="0" cy="640080"/>
           </a:xfrm>
           <a:prstGeom prst="line">
             <a:avLst/>
@@ -6515,9 +6450,9 @@
           <p:nvPr/>
         </p:nvCxnSpPr>
         <p:spPr>
-          <a:xfrm flipV="1">
-            <a:off x="10058400" y="1645920"/>
-            <a:ext cx="0" cy="640080"/>
+          <a:xfrm>
+            <a:off x="10058400" y="2286000"/>
+            <a:ext cx="548640" cy="274320"/>
           </a:xfrm>
           <a:prstGeom prst="line">
             <a:avLst/>
@@ -6550,8 +6485,8 @@
           <p:nvPr/>
         </p:nvCxnSpPr>
         <p:spPr>
-          <a:xfrm>
-            <a:off x="10058400" y="2286000"/>
+          <a:xfrm flipH="1">
+            <a:off x="9509760" y="2286000"/>
             <a:ext cx="548640" cy="274320"/>
           </a:xfrm>
           <a:prstGeom prst="line">
@@ -6578,44 +6513,9 @@
           </a:fontRef>
         </p:style>
       </p:cxnSp>
-      <p:cxnSp>
-        <p:nvCxnSpPr>
-          <p:cNvPr id="13" name="Connector 12"/>
-          <p:cNvCxnSpPr/>
-          <p:nvPr/>
-        </p:nvCxnSpPr>
-        <p:spPr>
-          <a:xfrm flipH="1">
-            <a:off x="9509760" y="2286000"/>
-            <a:ext cx="548640" cy="274320"/>
-          </a:xfrm>
-          <a:prstGeom prst="line">
-            <a:avLst/>
-          </a:prstGeom>
-          <a:ln w="38100">
-            <a:solidFill>
-              <a:srgbClr val="56705F"/>
-            </a:solidFill>
-          </a:ln>
-        </p:spPr>
-        <p:style>
-          <a:lnRef idx="2">
-            <a:schemeClr val="accent1"/>
-          </a:lnRef>
-          <a:fillRef idx="0">
-            <a:schemeClr val="accent1"/>
-          </a:fillRef>
-          <a:effectRef idx="1">
-            <a:schemeClr val="accent1"/>
-          </a:effectRef>
-          <a:fontRef idx="minor">
-            <a:schemeClr val="tx1"/>
-          </a:fontRef>
-        </p:style>
-      </p:cxnSp>
-      <p:sp>
-        <p:nvSpPr>
-          <p:cNvPr id="14" name="TextBox 13"/>
+      <p:sp>
+        <p:nvSpPr>
+          <p:cNvPr id="13" name="TextBox 12"/>
           <p:cNvSpPr txBox="1"/>
           <p:nvPr/>
         </p:nvSpPr>
@@ -6654,13 +6554,91 @@
       </p:sp>
       <p:sp>
         <p:nvSpPr>
+          <p:cNvPr id="14" name="TextBox 13"/>
+          <p:cNvSpPr txBox="1"/>
+          <p:nvPr/>
+        </p:nvSpPr>
+        <p:spPr>
+          <a:xfrm>
+            <a:off x="640080" y="3246120"/>
+            <a:ext cx="6400800" cy="411480"/>
+          </a:xfrm>
+          <a:prstGeom prst="rect">
+            <a:avLst/>
+          </a:prstGeom>
+          <a:noFill/>
+        </p:spPr>
+        <p:txBody>
+          <a:bodyPr wrap="square">
+            <a:spAutoFit/>
+          </a:bodyPr>
+          <a:lstStyle/>
+          <a:p>
+            <a:pPr>
+              <a:spcAft>
+                <a:spcPts val="1200"/>
+              </a:spcAft>
+              <a:defRPr sz="2000" b="0">
+                <a:solidFill>
+                  <a:srgbClr val="223E30"/>
+                </a:solidFill>
+                <a:latin typeface="Calibri"/>
+              </a:defRPr>
+            </a:pPr>
+            <a:r>
+              <a:t>Renewables 2025</a:t>
+            </a:r>
+          </a:p>
+        </p:txBody>
+      </p:sp>
+      <p:sp>
+        <p:nvSpPr>
           <p:cNvPr id="15" name="TextBox 14"/>
           <p:cNvSpPr txBox="1"/>
           <p:nvPr/>
         </p:nvSpPr>
         <p:spPr>
           <a:xfrm>
-            <a:off x="640080" y="5303520"/>
+            <a:off x="640080" y="3675887"/>
+            <a:ext cx="6400800" cy="320040"/>
+          </a:xfrm>
+          <a:prstGeom prst="rect">
+            <a:avLst/>
+          </a:prstGeom>
+          <a:noFill/>
+        </p:spPr>
+        <p:txBody>
+          <a:bodyPr wrap="square">
+            <a:spAutoFit/>
+          </a:bodyPr>
+          <a:lstStyle/>
+          <a:p>
+            <a:pPr>
+              <a:spcAft>
+                <a:spcPts val="1200"/>
+              </a:spcAft>
+              <a:defRPr sz="1400" b="0">
+                <a:solidFill>
+                  <a:srgbClr val="223E30"/>
+                </a:solidFill>
+                <a:latin typeface="Calibri"/>
+              </a:defRPr>
+            </a:pPr>
+            <a:r>
+              <a:t>International Energy Agency</a:t>
+            </a:r>
+          </a:p>
+        </p:txBody>
+      </p:sp>
+      <p:sp>
+        <p:nvSpPr>
+          <p:cNvPr id="16" name="TextBox 15"/>
+          <p:cNvSpPr txBox="1"/>
+          <p:nvPr/>
+        </p:nvSpPr>
+        <p:spPr>
+          <a:xfrm>
+            <a:off x="640080" y="4041648"/>
             <a:ext cx="6400800" cy="320040"/>
           </a:xfrm>
           <a:prstGeom prst="rect">
@@ -6696,13 +6674,91 @@
       </p:sp>
       <p:sp>
         <p:nvSpPr>
-          <p:cNvPr id="16" name="TextBox 15"/>
+          <p:cNvPr id="17" name="TextBox 16"/>
           <p:cNvSpPr txBox="1"/>
           <p:nvPr/>
         </p:nvSpPr>
         <p:spPr>
           <a:xfrm>
-            <a:off x="640080" y="5577840"/>
+            <a:off x="640080" y="4617720"/>
+            <a:ext cx="6400800" cy="411480"/>
+          </a:xfrm>
+          <a:prstGeom prst="rect">
+            <a:avLst/>
+          </a:prstGeom>
+          <a:noFill/>
+        </p:spPr>
+        <p:txBody>
+          <a:bodyPr wrap="square">
+            <a:spAutoFit/>
+          </a:bodyPr>
+          <a:lstStyle/>
+          <a:p>
+            <a:pPr>
+              <a:spcAft>
+                <a:spcPts val="1200"/>
+              </a:spcAft>
+              <a:defRPr sz="2000" b="0">
+                <a:solidFill>
+                  <a:srgbClr val="223E30"/>
+                </a:solidFill>
+                <a:latin typeface="Calibri"/>
+              </a:defRPr>
+            </a:pPr>
+            <a:r>
+              <a:t>Energy Storage</a:t>
+            </a:r>
+          </a:p>
+        </p:txBody>
+      </p:sp>
+      <p:sp>
+        <p:nvSpPr>
+          <p:cNvPr id="18" name="TextBox 17"/>
+          <p:cNvSpPr txBox="1"/>
+          <p:nvPr/>
+        </p:nvSpPr>
+        <p:spPr>
+          <a:xfrm>
+            <a:off x="640080" y="5047488"/>
+            <a:ext cx="6400800" cy="320040"/>
+          </a:xfrm>
+          <a:prstGeom prst="rect">
+            <a:avLst/>
+          </a:prstGeom>
+          <a:noFill/>
+        </p:spPr>
+        <p:txBody>
+          <a:bodyPr wrap="square">
+            <a:spAutoFit/>
+          </a:bodyPr>
+          <a:lstStyle/>
+          <a:p>
+            <a:pPr>
+              <a:spcAft>
+                <a:spcPts val="1200"/>
+              </a:spcAft>
+              <a:defRPr sz="1400" b="0">
+                <a:solidFill>
+                  <a:srgbClr val="223E30"/>
+                </a:solidFill>
+                <a:latin typeface="Calibri"/>
+              </a:defRPr>
+            </a:pPr>
+            <a:r>
+              <a:t>US Department of Energy</a:t>
+            </a:r>
+          </a:p>
+        </p:txBody>
+      </p:sp>
+      <p:sp>
+        <p:nvSpPr>
+          <p:cNvPr id="19" name="TextBox 18"/>
+          <p:cNvSpPr txBox="1"/>
+          <p:nvPr/>
+        </p:nvSpPr>
+        <p:spPr>
+          <a:xfrm>
+            <a:off x="640080" y="5413248"/>
             <a:ext cx="6400800" cy="320040"/>
           </a:xfrm>
           <a:prstGeom prst="rect">
@@ -6738,7 +6794,7 @@
       </p:sp>
       <p:sp>
         <p:nvSpPr>
-          <p:cNvPr id="17" name="TextBox 16"/>
+          <p:cNvPr id="20" name="TextBox 19"/>
           <p:cNvSpPr txBox="1"/>
           <p:nvPr/>
         </p:nvSpPr>

</xml_diff>

<commit_message>
feat(landing): present portrait report and separate widescreen deck exports
</commit_message>
<xml_diff>
--- a/frontend/public/landing/samples/clean-energy-briefing.pptx
+++ b/frontend/public/landing/samples/clean-energy-briefing.pptx
@@ -10,6 +10,7 @@
     <p:sldId id="258" r:id="rId10"/>
     <p:sldId id="259" r:id="rId11"/>
     <p:sldId id="260" r:id="rId12"/>
+    <p:sldId id="261" r:id="rId13"/>
   </p:sldIdLst>
   <p:sldSz cx="12191695" cy="6858000" type="screen4x3"/>
   <p:notesSz cx="6858000" cy="9144000"/>
@@ -772,6 +773,86 @@
 </file>
 
 <file path=ppt/notesSlides/notesSlide5.xml><?xml version="1.0" encoding="utf-8"?>
+<p:notes xmlns:a="http://schemas.openxmlformats.org/drawingml/2006/main" xmlns:p="http://schemas.openxmlformats.org/presentationml/2006/main" xmlns:r="http://schemas.openxmlformats.org/officeDocument/2006/relationships">
+  <p:cSld>
+    <p:spTree>
+      <p:nvGrpSpPr>
+        <p:cNvPr id="1" name=""/>
+        <p:cNvGrpSpPr/>
+        <p:nvPr/>
+      </p:nvGrpSpPr>
+      <p:grpSpPr>
+        <a:xfrm>
+          <a:off x="0" y="0"/>
+          <a:ext cx="0" cy="0"/>
+          <a:chOff x="0" y="0"/>
+          <a:chExt cx="0" cy="0"/>
+        </a:xfrm>
+      </p:grpSpPr>
+      <p:sp>
+        <p:nvSpPr>
+          <p:cNvPr id="2" name="Slide Image Placeholder 1"/>
+          <p:cNvSpPr>
+            <a:spLocks noGrp="1"/>
+          </p:cNvSpPr>
+          <p:nvPr>
+            <p:ph type="sldImg" idx="2"/>
+          </p:nvPr>
+        </p:nvSpPr>
+        <p:spPr/>
+      </p:sp>
+      <p:sp>
+        <p:nvSpPr>
+          <p:cNvPr id="3" name="Notes Placeholder 2"/>
+          <p:cNvSpPr>
+            <a:spLocks noGrp="1"/>
+          </p:cNvSpPr>
+          <p:nvPr>
+            <p:ph type="body" idx="3" sz="quarter"/>
+          </p:nvPr>
+        </p:nvSpPr>
+        <p:spPr/>
+        <p:txBody>
+          <a:bodyPr/>
+          <a:lstStyle/>
+          <a:p>
+            <a:r>
+              <a:t>Source-grounded sample. Separately authored presentation, not instant report conversion.</a:t>
+            </a:r>
+          </a:p>
+          <a:p>
+            <a:r>
+              <a:t>Renewables 2025: https://www.iea.org/reports/renewables-2025</a:t>
+            </a:r>
+          </a:p>
+          <a:p>
+            <a:r>
+              <a:t>Energy Storage: https://www.energy.gov/energy-storage</a:t>
+            </a:r>
+          </a:p>
+        </p:txBody>
+      </p:sp>
+      <p:sp>
+        <p:nvSpPr>
+          <p:cNvPr id="4" name="Slide Number Placeholder 3"/>
+          <p:cNvSpPr>
+            <a:spLocks noGrp="1"/>
+          </p:cNvSpPr>
+          <p:nvPr>
+            <p:ph type="sldNum" idx="5" sz="quarter"/>
+          </p:nvPr>
+        </p:nvSpPr>
+        <p:spPr/>
+      </p:sp>
+    </p:spTree>
+  </p:cSld>
+  <p:clrMapOvr>
+    <a:masterClrMapping/>
+  </p:clrMapOvr>
+</p:notes>
+</file>
+
+<file path=ppt/notesSlides/notesSlide6.xml><?xml version="1.0" encoding="utf-8"?>
 <p:notes xmlns:a="http://schemas.openxmlformats.org/drawingml/2006/main" xmlns:p="http://schemas.openxmlformats.org/presentationml/2006/main" xmlns:r="http://schemas.openxmlformats.org/officeDocument/2006/relationships">
   <p:cSld>
     <p:spTree>
@@ -3952,7 +4033,7 @@
               </a:defRPr>
             </a:pPr>
             <a:r>
-              <a:t>Renewables and the role of storage</a:t>
+              <a:t>A more resilient energy system.</a:t>
             </a:r>
           </a:p>
         </p:txBody>
@@ -4353,7 +4434,7 @@
               </a:defRPr>
             </a:pPr>
             <a:r>
-              <a:t>DocBuilder sample presentation                                      1 / 5</a:t>
+              <a:t>DocBuilder sample presentation                                      1 / 6</a:t>
             </a:r>
           </a:p>
         </p:txBody>
@@ -4457,7 +4538,7 @@
               </a:defRPr>
             </a:pPr>
             <a:r>
-              <a:t>The scope of the outlook</a:t>
+              <a:t>Market landscape</a:t>
             </a:r>
           </a:p>
         </p:txBody>
@@ -4929,7 +5010,7 @@
               </a:defRPr>
             </a:pPr>
             <a:r>
-              <a:t>DocBuilder sample presentation                                      2 / 5</a:t>
+              <a:t>DocBuilder sample presentation                                      2 / 6</a:t>
             </a:r>
           </a:p>
         </p:txBody>
@@ -5033,7 +5114,7 @@
               </a:defRPr>
             </a:pPr>
             <a:r>
-              <a:t>Storage connects supply and demand</a:t>
+              <a:t>Storage and flexibility</a:t>
             </a:r>
           </a:p>
         </p:txBody>
@@ -5505,7 +5586,7 @@
               </a:defRPr>
             </a:pPr>
             <a:r>
-              <a:t>DocBuilder sample presentation                                      3 / 5</a:t>
+              <a:t>DocBuilder sample presentation                                      3 / 6</a:t>
             </a:r>
           </a:p>
         </p:txBody>
@@ -5609,7 +5690,7 @@
               </a:defRPr>
             </a:pPr>
             <a:r>
-              <a:t>Decisions need local context</a:t>
+              <a:t>Risks and considerations</a:t>
             </a:r>
           </a:p>
         </p:txBody>
@@ -6081,7 +6162,7 @@
               </a:defRPr>
             </a:pPr>
             <a:r>
-              <a:t>DocBuilder sample presentation                                      4 / 5</a:t>
+              <a:t>DocBuilder sample presentation                                      4 / 6</a:t>
             </a:r>
           </a:p>
         </p:txBody>
@@ -6146,7 +6227,7 @@
               </a:defRPr>
             </a:pPr>
             <a:r>
-              <a:t>CONTINUE THE RESEARCH</a:t>
+              <a:t>FROM CONTEXT TO A DECISION</a:t>
             </a:r>
           </a:p>
         </p:txBody>
@@ -6185,14 +6266,85 @@
               </a:defRPr>
             </a:pPr>
             <a:r>
-              <a:t>References</a:t>
-            </a:r>
-          </a:p>
-        </p:txBody>
-      </p:sp>
-      <p:sp>
-        <p:nvSpPr>
-          <p:cNvPr id="4" name="Rectangle 3"/>
+              <a:t>Next steps</a:t>
+            </a:r>
+          </a:p>
+        </p:txBody>
+      </p:sp>
+      <p:sp>
+        <p:nvSpPr>
+          <p:cNvPr id="4" name="TextBox 3"/>
+          <p:cNvSpPr txBox="1"/>
+          <p:nvPr/>
+        </p:nvSpPr>
+        <p:spPr>
+          <a:xfrm>
+            <a:off x="640080" y="3383280"/>
+            <a:ext cx="6400800" cy="2286000"/>
+          </a:xfrm>
+          <a:prstGeom prst="rect">
+            <a:avLst/>
+          </a:prstGeom>
+          <a:noFill/>
+        </p:spPr>
+        <p:txBody>
+          <a:bodyPr wrap="square">
+            <a:spAutoFit/>
+          </a:bodyPr>
+          <a:lstStyle/>
+          <a:p>
+            <a:pPr>
+              <a:spcAft>
+                <a:spcPts val="1200"/>
+              </a:spcAft>
+              <a:defRPr sz="2300" b="0">
+                <a:solidFill>
+                  <a:srgbClr val="223E30"/>
+                </a:solidFill>
+                <a:latin typeface="Calibri"/>
+              </a:defRPr>
+            </a:pPr>
+            <a:r>
+              <a:t>Read the original sources</a:t>
+            </a:r>
+          </a:p>
+          <a:p>
+            <a:pPr>
+              <a:spcAft>
+                <a:spcPts val="1200"/>
+              </a:spcAft>
+              <a:defRPr sz="2300" b="0">
+                <a:solidFill>
+                  <a:srgbClr val="223E30"/>
+                </a:solidFill>
+                <a:latin typeface="Calibri"/>
+              </a:defRPr>
+            </a:pPr>
+            <a:r>
+              <a:t>Document assumptions</a:t>
+            </a:r>
+          </a:p>
+          <a:p>
+            <a:pPr>
+              <a:spcAft>
+                <a:spcPts val="1200"/>
+              </a:spcAft>
+              <a:defRPr sz="2300" b="0">
+                <a:solidFill>
+                  <a:srgbClr val="223E30"/>
+                </a:solidFill>
+                <a:latin typeface="Calibri"/>
+              </a:defRPr>
+            </a:pPr>
+            <a:r>
+              <a:t>Assess project-specific storage needs</a:t>
+            </a:r>
+          </a:p>
+        </p:txBody>
+      </p:sp>
+      <p:sp>
+        <p:nvSpPr>
+          <p:cNvPr id="5" name="Rectangle 4"/>
           <p:cNvSpPr/>
           <p:nvPr/>
         </p:nvSpPr>
@@ -6235,7 +6387,7 @@
       </p:sp>
       <p:cxnSp>
         <p:nvCxnSpPr>
-          <p:cNvPr id="5" name="Connector 4"/>
+          <p:cNvPr id="6" name="Connector 5"/>
           <p:cNvCxnSpPr/>
           <p:nvPr/>
         </p:nvCxnSpPr>
@@ -6243,41 +6395,6 @@
           <a:xfrm>
             <a:off x="8686800" y="3108960"/>
             <a:ext cx="0" cy="1920240"/>
-          </a:xfrm>
-          <a:prstGeom prst="line">
-            <a:avLst/>
-          </a:prstGeom>
-          <a:ln w="38100">
-            <a:solidFill>
-              <a:srgbClr val="56705F"/>
-            </a:solidFill>
-          </a:ln>
-        </p:spPr>
-        <p:style>
-          <a:lnRef idx="2">
-            <a:schemeClr val="accent1"/>
-          </a:lnRef>
-          <a:fillRef idx="0">
-            <a:schemeClr val="accent1"/>
-          </a:fillRef>
-          <a:effectRef idx="1">
-            <a:schemeClr val="accent1"/>
-          </a:effectRef>
-          <a:fontRef idx="minor">
-            <a:schemeClr val="tx1"/>
-          </a:fontRef>
-        </p:style>
-      </p:cxnSp>
-      <p:cxnSp>
-        <p:nvCxnSpPr>
-          <p:cNvPr id="6" name="Connector 5"/>
-          <p:cNvCxnSpPr/>
-          <p:nvPr/>
-        </p:nvCxnSpPr>
-        <p:spPr>
-          <a:xfrm flipV="1">
-            <a:off x="8686800" y="2468880"/>
-            <a:ext cx="0" cy="640080"/>
           </a:xfrm>
           <a:prstGeom prst="line">
             <a:avLst/>
@@ -6310,9 +6427,9 @@
           <p:nvPr/>
         </p:nvCxnSpPr>
         <p:spPr>
-          <a:xfrm>
-            <a:off x="8686800" y="3108960"/>
-            <a:ext cx="548640" cy="274319"/>
+          <a:xfrm flipV="1">
+            <a:off x="8686800" y="2468880"/>
+            <a:ext cx="0" cy="640080"/>
           </a:xfrm>
           <a:prstGeom prst="line">
             <a:avLst/>
@@ -6345,8 +6462,8 @@
           <p:nvPr/>
         </p:nvCxnSpPr>
         <p:spPr>
-          <a:xfrm flipH="1">
-            <a:off x="8138160" y="3108960"/>
+          <a:xfrm>
+            <a:off x="8686800" y="3108960"/>
             <a:ext cx="548640" cy="274319"/>
           </a:xfrm>
           <a:prstGeom prst="line">
@@ -6380,9 +6497,9 @@
           <p:nvPr/>
         </p:nvCxnSpPr>
         <p:spPr>
-          <a:xfrm>
-            <a:off x="10058400" y="2286000"/>
-            <a:ext cx="0" cy="2743200"/>
+          <a:xfrm flipH="1">
+            <a:off x="8138160" y="3108960"/>
+            <a:ext cx="548640" cy="274319"/>
           </a:xfrm>
           <a:prstGeom prst="line">
             <a:avLst/>
@@ -6415,9 +6532,9 @@
           <p:nvPr/>
         </p:nvCxnSpPr>
         <p:spPr>
-          <a:xfrm flipV="1">
-            <a:off x="10058400" y="1645920"/>
-            <a:ext cx="0" cy="640080"/>
+          <a:xfrm>
+            <a:off x="10058400" y="2286000"/>
+            <a:ext cx="0" cy="2743200"/>
           </a:xfrm>
           <a:prstGeom prst="line">
             <a:avLst/>
@@ -6450,9 +6567,9 @@
           <p:nvPr/>
         </p:nvCxnSpPr>
         <p:spPr>
-          <a:xfrm>
-            <a:off x="10058400" y="2286000"/>
-            <a:ext cx="548640" cy="274320"/>
+          <a:xfrm flipV="1">
+            <a:off x="10058400" y="1645920"/>
+            <a:ext cx="0" cy="640080"/>
           </a:xfrm>
           <a:prstGeom prst="line">
             <a:avLst/>
@@ -6485,8 +6602,8 @@
           <p:nvPr/>
         </p:nvCxnSpPr>
         <p:spPr>
-          <a:xfrm flipH="1">
-            <a:off x="9509760" y="2286000"/>
+          <a:xfrm>
+            <a:off x="10058400" y="2286000"/>
             <a:ext cx="548640" cy="274320"/>
           </a:xfrm>
           <a:prstGeom prst="line">
@@ -6513,9 +6630,44 @@
           </a:fontRef>
         </p:style>
       </p:cxnSp>
-      <p:sp>
-        <p:nvSpPr>
-          <p:cNvPr id="13" name="TextBox 12"/>
+      <p:cxnSp>
+        <p:nvCxnSpPr>
+          <p:cNvPr id="13" name="Connector 12"/>
+          <p:cNvCxnSpPr/>
+          <p:nvPr/>
+        </p:nvCxnSpPr>
+        <p:spPr>
+          <a:xfrm flipH="1">
+            <a:off x="9509760" y="2286000"/>
+            <a:ext cx="548640" cy="274320"/>
+          </a:xfrm>
+          <a:prstGeom prst="line">
+            <a:avLst/>
+          </a:prstGeom>
+          <a:ln w="38100">
+            <a:solidFill>
+              <a:srgbClr val="56705F"/>
+            </a:solidFill>
+          </a:ln>
+        </p:spPr>
+        <p:style>
+          <a:lnRef idx="2">
+            <a:schemeClr val="accent1"/>
+          </a:lnRef>
+          <a:fillRef idx="0">
+            <a:schemeClr val="accent1"/>
+          </a:fillRef>
+          <a:effectRef idx="1">
+            <a:schemeClr val="accent1"/>
+          </a:effectRef>
+          <a:fontRef idx="minor">
+            <a:schemeClr val="tx1"/>
+          </a:fontRef>
+        </p:style>
+      </p:cxnSp>
+      <p:sp>
+        <p:nvSpPr>
+          <p:cNvPr id="14" name="TextBox 13"/>
           <p:cNvSpPr txBox="1"/>
           <p:nvPr/>
         </p:nvSpPr>
@@ -6554,6 +6706,511 @@
       </p:sp>
       <p:sp>
         <p:nvSpPr>
+          <p:cNvPr id="15" name="TextBox 14"/>
+          <p:cNvSpPr txBox="1"/>
+          <p:nvPr/>
+        </p:nvSpPr>
+        <p:spPr>
+          <a:xfrm>
+            <a:off x="640080" y="6126480"/>
+            <a:ext cx="10789920" cy="411480"/>
+          </a:xfrm>
+          <a:prstGeom prst="rect">
+            <a:avLst/>
+          </a:prstGeom>
+          <a:noFill/>
+        </p:spPr>
+        <p:txBody>
+          <a:bodyPr wrap="square">
+            <a:spAutoFit/>
+          </a:bodyPr>
+          <a:lstStyle/>
+          <a:p>
+            <a:pPr>
+              <a:spcAft>
+                <a:spcPts val="1200"/>
+              </a:spcAft>
+              <a:defRPr sz="1200" b="0">
+                <a:solidFill>
+                  <a:srgbClr val="223E30"/>
+                </a:solidFill>
+                <a:latin typeface="Calibri"/>
+              </a:defRPr>
+            </a:pPr>
+            <a:r>
+              <a:t>DocBuilder sample presentation                                      5 / 6</a:t>
+            </a:r>
+          </a:p>
+        </p:txBody>
+      </p:sp>
+    </p:spTree>
+  </p:cSld>
+  <p:clrMapOvr>
+    <a:masterClrMapping/>
+  </p:clrMapOvr>
+</p:sld>
+</file>
+
+<file path=ppt/slides/slide6.xml><?xml version="1.0" encoding="utf-8"?>
+<p:sld xmlns:a="http://schemas.openxmlformats.org/drawingml/2006/main" xmlns:p="http://schemas.openxmlformats.org/presentationml/2006/main" xmlns:r="http://schemas.openxmlformats.org/officeDocument/2006/relationships">
+  <p:cSld>
+    <p:bg>
+      <p:bgPr>
+        <a:solidFill>
+          <a:srgbClr val="F6F4EB"/>
+        </a:solidFill>
+        <a:effectLst/>
+      </p:bgPr>
+    </p:bg>
+    <p:spTree>
+      <p:nvGrpSpPr>
+        <p:cNvPr id="1" name=""/>
+        <p:cNvGrpSpPr/>
+        <p:nvPr/>
+      </p:nvGrpSpPr>
+      <p:grpSpPr/>
+      <p:sp>
+        <p:nvSpPr>
+          <p:cNvPr id="2" name="TextBox 1"/>
+          <p:cNvSpPr txBox="1"/>
+          <p:nvPr/>
+        </p:nvSpPr>
+        <p:spPr>
+          <a:xfrm>
+            <a:off x="640080" y="457200"/>
+            <a:ext cx="10058400" cy="457200"/>
+          </a:xfrm>
+          <a:prstGeom prst="rect">
+            <a:avLst/>
+          </a:prstGeom>
+          <a:noFill/>
+        </p:spPr>
+        <p:txBody>
+          <a:bodyPr wrap="square">
+            <a:spAutoFit/>
+          </a:bodyPr>
+          <a:lstStyle/>
+          <a:p>
+            <a:pPr>
+              <a:spcAft>
+                <a:spcPts val="1200"/>
+              </a:spcAft>
+              <a:defRPr sz="1400" b="0">
+                <a:solidFill>
+                  <a:srgbClr val="223E30"/>
+                </a:solidFill>
+                <a:latin typeface="Calibri"/>
+              </a:defRPr>
+            </a:pPr>
+            <a:r>
+              <a:t>CONTINUE THE RESEARCH</a:t>
+            </a:r>
+          </a:p>
+        </p:txBody>
+      </p:sp>
+      <p:sp>
+        <p:nvSpPr>
+          <p:cNvPr id="3" name="TextBox 2"/>
+          <p:cNvSpPr txBox="1"/>
+          <p:nvPr/>
+        </p:nvSpPr>
+        <p:spPr>
+          <a:xfrm>
+            <a:off x="640080" y="1280160"/>
+            <a:ext cx="6400800" cy="1828800"/>
+          </a:xfrm>
+          <a:prstGeom prst="rect">
+            <a:avLst/>
+          </a:prstGeom>
+          <a:noFill/>
+        </p:spPr>
+        <p:txBody>
+          <a:bodyPr wrap="square">
+            <a:spAutoFit/>
+          </a:bodyPr>
+          <a:lstStyle/>
+          <a:p>
+            <a:pPr>
+              <a:spcAft>
+                <a:spcPts val="1200"/>
+              </a:spcAft>
+              <a:defRPr sz="3600" b="1">
+                <a:solidFill>
+                  <a:srgbClr val="223E30"/>
+                </a:solidFill>
+                <a:latin typeface="Calibri"/>
+              </a:defRPr>
+            </a:pPr>
+            <a:r>
+              <a:t>References</a:t>
+            </a:r>
+          </a:p>
+        </p:txBody>
+      </p:sp>
+      <p:sp>
+        <p:nvSpPr>
+          <p:cNvPr id="4" name="Rectangle 3"/>
+          <p:cNvSpPr/>
+          <p:nvPr/>
+        </p:nvSpPr>
+        <p:spPr>
+          <a:xfrm>
+            <a:off x="7955279" y="1280160"/>
+            <a:ext cx="3474720" cy="4389120"/>
+          </a:xfrm>
+          <a:prstGeom prst="rect">
+            <a:avLst/>
+          </a:prstGeom>
+          <a:solidFill>
+            <a:srgbClr val="D9E4CF"/>
+          </a:solidFill>
+          <a:ln>
+            <a:noFill/>
+          </a:ln>
+        </p:spPr>
+        <p:style>
+          <a:lnRef idx="1">
+            <a:schemeClr val="accent1"/>
+          </a:lnRef>
+          <a:fillRef idx="3">
+            <a:schemeClr val="accent1"/>
+          </a:fillRef>
+          <a:effectRef idx="2">
+            <a:schemeClr val="accent1"/>
+          </a:effectRef>
+          <a:fontRef idx="minor">
+            <a:schemeClr val="lt1"/>
+          </a:fontRef>
+        </p:style>
+        <p:txBody>
+          <a:bodyPr rtlCol="0" anchor="ctr"/>
+          <a:lstStyle/>
+          <a:p>
+            <a:pPr algn="ctr"/>
+          </a:p>
+        </p:txBody>
+      </p:sp>
+      <p:cxnSp>
+        <p:nvCxnSpPr>
+          <p:cNvPr id="5" name="Connector 4"/>
+          <p:cNvCxnSpPr/>
+          <p:nvPr/>
+        </p:nvCxnSpPr>
+        <p:spPr>
+          <a:xfrm>
+            <a:off x="8686800" y="3108960"/>
+            <a:ext cx="0" cy="1920240"/>
+          </a:xfrm>
+          <a:prstGeom prst="line">
+            <a:avLst/>
+          </a:prstGeom>
+          <a:ln w="38100">
+            <a:solidFill>
+              <a:srgbClr val="56705F"/>
+            </a:solidFill>
+          </a:ln>
+        </p:spPr>
+        <p:style>
+          <a:lnRef idx="2">
+            <a:schemeClr val="accent1"/>
+          </a:lnRef>
+          <a:fillRef idx="0">
+            <a:schemeClr val="accent1"/>
+          </a:fillRef>
+          <a:effectRef idx="1">
+            <a:schemeClr val="accent1"/>
+          </a:effectRef>
+          <a:fontRef idx="minor">
+            <a:schemeClr val="tx1"/>
+          </a:fontRef>
+        </p:style>
+      </p:cxnSp>
+      <p:cxnSp>
+        <p:nvCxnSpPr>
+          <p:cNvPr id="6" name="Connector 5"/>
+          <p:cNvCxnSpPr/>
+          <p:nvPr/>
+        </p:nvCxnSpPr>
+        <p:spPr>
+          <a:xfrm flipV="1">
+            <a:off x="8686800" y="2468880"/>
+            <a:ext cx="0" cy="640080"/>
+          </a:xfrm>
+          <a:prstGeom prst="line">
+            <a:avLst/>
+          </a:prstGeom>
+          <a:ln w="38100">
+            <a:solidFill>
+              <a:srgbClr val="56705F"/>
+            </a:solidFill>
+          </a:ln>
+        </p:spPr>
+        <p:style>
+          <a:lnRef idx="2">
+            <a:schemeClr val="accent1"/>
+          </a:lnRef>
+          <a:fillRef idx="0">
+            <a:schemeClr val="accent1"/>
+          </a:fillRef>
+          <a:effectRef idx="1">
+            <a:schemeClr val="accent1"/>
+          </a:effectRef>
+          <a:fontRef idx="minor">
+            <a:schemeClr val="tx1"/>
+          </a:fontRef>
+        </p:style>
+      </p:cxnSp>
+      <p:cxnSp>
+        <p:nvCxnSpPr>
+          <p:cNvPr id="7" name="Connector 6"/>
+          <p:cNvCxnSpPr/>
+          <p:nvPr/>
+        </p:nvCxnSpPr>
+        <p:spPr>
+          <a:xfrm>
+            <a:off x="8686800" y="3108960"/>
+            <a:ext cx="548640" cy="274319"/>
+          </a:xfrm>
+          <a:prstGeom prst="line">
+            <a:avLst/>
+          </a:prstGeom>
+          <a:ln w="38100">
+            <a:solidFill>
+              <a:srgbClr val="56705F"/>
+            </a:solidFill>
+          </a:ln>
+        </p:spPr>
+        <p:style>
+          <a:lnRef idx="2">
+            <a:schemeClr val="accent1"/>
+          </a:lnRef>
+          <a:fillRef idx="0">
+            <a:schemeClr val="accent1"/>
+          </a:fillRef>
+          <a:effectRef idx="1">
+            <a:schemeClr val="accent1"/>
+          </a:effectRef>
+          <a:fontRef idx="minor">
+            <a:schemeClr val="tx1"/>
+          </a:fontRef>
+        </p:style>
+      </p:cxnSp>
+      <p:cxnSp>
+        <p:nvCxnSpPr>
+          <p:cNvPr id="8" name="Connector 7"/>
+          <p:cNvCxnSpPr/>
+          <p:nvPr/>
+        </p:nvCxnSpPr>
+        <p:spPr>
+          <a:xfrm flipH="1">
+            <a:off x="8138160" y="3108960"/>
+            <a:ext cx="548640" cy="274319"/>
+          </a:xfrm>
+          <a:prstGeom prst="line">
+            <a:avLst/>
+          </a:prstGeom>
+          <a:ln w="38100">
+            <a:solidFill>
+              <a:srgbClr val="56705F"/>
+            </a:solidFill>
+          </a:ln>
+        </p:spPr>
+        <p:style>
+          <a:lnRef idx="2">
+            <a:schemeClr val="accent1"/>
+          </a:lnRef>
+          <a:fillRef idx="0">
+            <a:schemeClr val="accent1"/>
+          </a:fillRef>
+          <a:effectRef idx="1">
+            <a:schemeClr val="accent1"/>
+          </a:effectRef>
+          <a:fontRef idx="minor">
+            <a:schemeClr val="tx1"/>
+          </a:fontRef>
+        </p:style>
+      </p:cxnSp>
+      <p:cxnSp>
+        <p:nvCxnSpPr>
+          <p:cNvPr id="9" name="Connector 8"/>
+          <p:cNvCxnSpPr/>
+          <p:nvPr/>
+        </p:nvCxnSpPr>
+        <p:spPr>
+          <a:xfrm>
+            <a:off x="10058400" y="2286000"/>
+            <a:ext cx="0" cy="2743200"/>
+          </a:xfrm>
+          <a:prstGeom prst="line">
+            <a:avLst/>
+          </a:prstGeom>
+          <a:ln w="38100">
+            <a:solidFill>
+              <a:srgbClr val="56705F"/>
+            </a:solidFill>
+          </a:ln>
+        </p:spPr>
+        <p:style>
+          <a:lnRef idx="2">
+            <a:schemeClr val="accent1"/>
+          </a:lnRef>
+          <a:fillRef idx="0">
+            <a:schemeClr val="accent1"/>
+          </a:fillRef>
+          <a:effectRef idx="1">
+            <a:schemeClr val="accent1"/>
+          </a:effectRef>
+          <a:fontRef idx="minor">
+            <a:schemeClr val="tx1"/>
+          </a:fontRef>
+        </p:style>
+      </p:cxnSp>
+      <p:cxnSp>
+        <p:nvCxnSpPr>
+          <p:cNvPr id="10" name="Connector 9"/>
+          <p:cNvCxnSpPr/>
+          <p:nvPr/>
+        </p:nvCxnSpPr>
+        <p:spPr>
+          <a:xfrm flipV="1">
+            <a:off x="10058400" y="1645920"/>
+            <a:ext cx="0" cy="640080"/>
+          </a:xfrm>
+          <a:prstGeom prst="line">
+            <a:avLst/>
+          </a:prstGeom>
+          <a:ln w="38100">
+            <a:solidFill>
+              <a:srgbClr val="56705F"/>
+            </a:solidFill>
+          </a:ln>
+        </p:spPr>
+        <p:style>
+          <a:lnRef idx="2">
+            <a:schemeClr val="accent1"/>
+          </a:lnRef>
+          <a:fillRef idx="0">
+            <a:schemeClr val="accent1"/>
+          </a:fillRef>
+          <a:effectRef idx="1">
+            <a:schemeClr val="accent1"/>
+          </a:effectRef>
+          <a:fontRef idx="minor">
+            <a:schemeClr val="tx1"/>
+          </a:fontRef>
+        </p:style>
+      </p:cxnSp>
+      <p:cxnSp>
+        <p:nvCxnSpPr>
+          <p:cNvPr id="11" name="Connector 10"/>
+          <p:cNvCxnSpPr/>
+          <p:nvPr/>
+        </p:nvCxnSpPr>
+        <p:spPr>
+          <a:xfrm>
+            <a:off x="10058400" y="2286000"/>
+            <a:ext cx="548640" cy="274320"/>
+          </a:xfrm>
+          <a:prstGeom prst="line">
+            <a:avLst/>
+          </a:prstGeom>
+          <a:ln w="38100">
+            <a:solidFill>
+              <a:srgbClr val="56705F"/>
+            </a:solidFill>
+          </a:ln>
+        </p:spPr>
+        <p:style>
+          <a:lnRef idx="2">
+            <a:schemeClr val="accent1"/>
+          </a:lnRef>
+          <a:fillRef idx="0">
+            <a:schemeClr val="accent1"/>
+          </a:fillRef>
+          <a:effectRef idx="1">
+            <a:schemeClr val="accent1"/>
+          </a:effectRef>
+          <a:fontRef idx="minor">
+            <a:schemeClr val="tx1"/>
+          </a:fontRef>
+        </p:style>
+      </p:cxnSp>
+      <p:cxnSp>
+        <p:nvCxnSpPr>
+          <p:cNvPr id="12" name="Connector 11"/>
+          <p:cNvCxnSpPr/>
+          <p:nvPr/>
+        </p:nvCxnSpPr>
+        <p:spPr>
+          <a:xfrm flipH="1">
+            <a:off x="9509760" y="2286000"/>
+            <a:ext cx="548640" cy="274320"/>
+          </a:xfrm>
+          <a:prstGeom prst="line">
+            <a:avLst/>
+          </a:prstGeom>
+          <a:ln w="38100">
+            <a:solidFill>
+              <a:srgbClr val="56705F"/>
+            </a:solidFill>
+          </a:ln>
+        </p:spPr>
+        <p:style>
+          <a:lnRef idx="2">
+            <a:schemeClr val="accent1"/>
+          </a:lnRef>
+          <a:fillRef idx="0">
+            <a:schemeClr val="accent1"/>
+          </a:fillRef>
+          <a:effectRef idx="1">
+            <a:schemeClr val="accent1"/>
+          </a:effectRef>
+          <a:fontRef idx="minor">
+            <a:schemeClr val="tx1"/>
+          </a:fontRef>
+        </p:style>
+      </p:cxnSp>
+      <p:sp>
+        <p:nvSpPr>
+          <p:cNvPr id="13" name="TextBox 12"/>
+          <p:cNvSpPr txBox="1"/>
+          <p:nvPr/>
+        </p:nvSpPr>
+        <p:spPr>
+          <a:xfrm>
+            <a:off x="8138160" y="5212080"/>
+            <a:ext cx="3108960" cy="365760"/>
+          </a:xfrm>
+          <a:prstGeom prst="rect">
+            <a:avLst/>
+          </a:prstGeom>
+          <a:noFill/>
+        </p:spPr>
+        <p:txBody>
+          <a:bodyPr wrap="square">
+            <a:spAutoFit/>
+          </a:bodyPr>
+          <a:lstStyle/>
+          <a:p>
+            <a:pPr>
+              <a:spcAft>
+                <a:spcPts val="1200"/>
+              </a:spcAft>
+              <a:defRPr sz="1000" b="0">
+                <a:solidFill>
+                  <a:srgbClr val="223E30"/>
+                </a:solidFill>
+                <a:latin typeface="Calibri"/>
+              </a:defRPr>
+            </a:pPr>
+            <a:r>
+              <a:t>Schematic illustration</a:t>
+            </a:r>
+          </a:p>
+        </p:txBody>
+      </p:sp>
+      <p:sp>
+        <p:nvSpPr>
           <p:cNvPr id="14" name="TextBox 13"/>
           <p:cNvSpPr txBox="1"/>
           <p:nvPr/>
@@ -6625,7 +7282,7 @@
               </a:defRPr>
             </a:pPr>
             <a:r>
-              <a:t>International Energy Agency</a:t>
+              <a:t>IEA</a:t>
             </a:r>
           </a:p>
         </p:txBody>
@@ -6826,7 +7483,7 @@
               </a:defRPr>
             </a:pPr>
             <a:r>
-              <a:t>DocBuilder sample presentation                                      5 / 5</a:t>
+              <a:t>DocBuilder sample presentation                                      6 / 6</a:t>
             </a:r>
           </a:p>
         </p:txBody>

</xml_diff>